<commit_message>
updated figures and supplemental tables
</commit_message>
<xml_diff>
--- a/figures/Supplemental_Figures/Supp_Figures.pptx
+++ b/figures/Supplemental_Figures/Supp_Figures.pptx
@@ -5810,36 +5810,6 @@
           </a:prstGeom>
         </p:spPr>
       </p:pic>
-      <p:pic>
-        <p:nvPicPr>
-          <p:cNvPr id="5" name="Picture 4">
-            <a:extLst>
-              <a:ext uri="{FF2B5EF4-FFF2-40B4-BE49-F238E27FC236}">
-                <a16:creationId xmlns:a16="http://schemas.microsoft.com/office/drawing/2014/main" id="{ACE4B6DF-57C1-20E9-0254-F5E455775A9C}"/>
-              </a:ext>
-            </a:extLst>
-          </p:cNvPr>
-          <p:cNvPicPr>
-            <a:picLocks noChangeAspect="1"/>
-          </p:cNvPicPr>
-          <p:nvPr/>
-        </p:nvPicPr>
-        <p:blipFill>
-          <a:blip r:embed="rId3"/>
-          <a:stretch>
-            <a:fillRect/>
-          </a:stretch>
-        </p:blipFill>
-        <p:spPr>
-          <a:xfrm>
-            <a:off x="255214" y="3086869"/>
-            <a:ext cx="6319114" cy="2892811"/>
-          </a:xfrm>
-          <a:prstGeom prst="rect">
-            <a:avLst/>
-          </a:prstGeom>
-        </p:spPr>
-      </p:pic>
       <p:sp>
         <p:nvSpPr>
           <p:cNvPr id="6" name="TextBox 5">
@@ -5960,7 +5930,7 @@
           <p:nvPr/>
         </p:nvPicPr>
         <p:blipFill>
-          <a:blip r:embed="rId4"/>
+          <a:blip r:embed="rId3"/>
           <a:srcRect l="48438" b="53873"/>
           <a:stretch>
             <a:fillRect/>
@@ -5991,7 +5961,7 @@
           <p:nvPr/>
         </p:nvPicPr>
         <p:blipFill>
-          <a:blip r:embed="rId4"/>
+          <a:blip r:embed="rId3"/>
           <a:srcRect t="46070"/>
           <a:stretch>
             <a:fillRect/>
@@ -6111,7 +6081,7 @@
             </a:r>
             <a:r>
               <a:rPr lang="en-CA" sz="1100" dirty="0"/>
-              <a:t> call (PD/SD/PR/CR; PD and SD collapsed to Resistant, PR and CR to Sensitive for comparison); the two response definitions agree for 76.2% of models (61/80). (c) Full pre-ranked GSEA results (top 6 pathways per direction, FDR q &lt; 0.05) against GO Biological Process, KEGG, and </a:t>
+              <a:t> call (PD/SD/PR/CR; PD and SD collapsed to Resistant, PR and CR to Sensitive for comparison); the two response definitions agree for 76.2% of models (61/80). (c) GSEA results against GO Biological Process, KEGG, and </a:t>
             </a:r>
             <a:r>
               <a:rPr lang="en-CA" sz="1100" dirty="0" err="1"/>
@@ -6119,7 +6089,15 @@
             </a:r>
             <a:r>
               <a:rPr lang="en-CA" sz="1100" dirty="0"/>
-              <a:t> Hallmark gene sets, ranked by Welch's t-statistic (Sensitive vs. Resistant, fixed </a:t>
+              <a:t> Hallmark gene sets, ranked by </a:t>
+            </a:r>
+            <a:r>
+              <a:rPr lang="en-CA" sz="1100" dirty="0" err="1"/>
+              <a:t>limma</a:t>
+            </a:r>
+            <a:r>
+              <a:rPr lang="en-CA" sz="1100" dirty="0"/>
+              <a:t> moderated t-statistics (Sensitive vs. Resistant, fixed </a:t>
             </a:r>
             <a:r>
               <a:rPr lang="en-CA" sz="1100" dirty="0" err="1"/>
@@ -6135,11 +6113,46 @@
             </a:r>
             <a:r>
               <a:rPr lang="en-CA" sz="1100" dirty="0"/>
-              <a:t> transcriptome). Positive NES: enriched in Sensitive models; negative NES: enriched in Resistant models.</a:t>
-            </a:r>
-          </a:p>
-        </p:txBody>
-      </p:sp>
+              <a:t> transcriptome). Positive NES: enriched in Sensitive models; negative NES: enriched in </a:t>
+            </a:r>
+            <a:r>
+              <a:rPr lang="en-CA" sz="1100"/>
+              <a:t>Resistant models (FDR q &lt; 0.05) .</a:t>
+            </a:r>
+            <a:endParaRPr lang="en-CA" sz="1100" dirty="0"/>
+          </a:p>
+        </p:txBody>
+      </p:sp>
+      <p:pic>
+        <p:nvPicPr>
+          <p:cNvPr id="3" name="Picture 2">
+            <a:extLst>
+              <a:ext uri="{FF2B5EF4-FFF2-40B4-BE49-F238E27FC236}">
+                <a16:creationId xmlns:a16="http://schemas.microsoft.com/office/drawing/2014/main" id="{0E0CFC7A-79E4-95A9-59D0-E06126269010}"/>
+              </a:ext>
+            </a:extLst>
+          </p:cNvPr>
+          <p:cNvPicPr>
+            <a:picLocks noChangeAspect="1"/>
+          </p:cNvPicPr>
+          <p:nvPr/>
+        </p:nvPicPr>
+        <p:blipFill>
+          <a:blip r:embed="rId4"/>
+          <a:stretch>
+            <a:fillRect/>
+          </a:stretch>
+        </p:blipFill>
+        <p:spPr>
+          <a:xfrm>
+            <a:off x="0" y="3471518"/>
+            <a:ext cx="6858000" cy="2200963"/>
+          </a:xfrm>
+          <a:prstGeom prst="rect">
+            <a:avLst/>
+          </a:prstGeom>
+        </p:spPr>
+      </p:pic>
     </p:spTree>
     <p:extLst>
       <p:ext uri="{BB962C8B-B14F-4D97-AF65-F5344CB8AC3E}">

</xml_diff>